<commit_message>
Move the in-layer labels onto the side face
The schematics this imitates put the layer names on the block's right-hand
face, not the front one, over a chunky block rather than a wide shallow
slab.  IBW/IBD go 340/110 -> 300/215, and the label anchor moves from
P(IBW/2, IBD) to P(IBW, IBD/2).

IBD is now what limits a label, since the face a label sits on is IEX*IBD
wide rather than IEX*IBW.  The ink threshold moves with the face too: the
side is shaded 0.86 against the front's 0.70, so the same layer colour
lands on the other side of the light-ink cutoff.

Co-Authored-By: Claude Opus 5 <noreply@anthropic.com>
Claude-Session: https://claude.ai/code/session_014A61zHZtLZU5uPXAWC8gtS
</commit_message>
<xml_diff>
--- a/figures/device_stack_electrode_boxed.pptx
+++ b/figures/device_stack_electrode_boxed.pptx
@@ -3096,8 +3096,8 @@
         </p:nvSpPr>
         <p:spPr>
           <a:xfrm>
-            <a:off x="7038091" y="4660362"/>
-            <a:ext cx="900444" cy="771560"/>
+            <a:off x="6443311" y="4496209"/>
+            <a:ext cx="1759958" cy="1009299"/>
           </a:xfrm>
           <a:custGeom>
             <a:avLst/>
@@ -3106,18 +3106,18 @@
             <a:cxnLst/>
             <a:rect l="l" t="t" r="r" b="b"/>
             <a:pathLst>
-              <a:path w="900444" h="771560">
+              <a:path w="1759958" h="1009299">
                 <a:moveTo>
-                  <a:pt x="900444" y="522501"/>
+                  <a:pt x="1759958" y="522502"/>
                 </a:moveTo>
                 <a:lnTo>
-                  <a:pt x="900444" y="0"/>
+                  <a:pt x="1759958" y="0"/>
                 </a:lnTo>
                 <a:lnTo>
-                  <a:pt x="0" y="249059"/>
+                  <a:pt x="0" y="486797"/>
                 </a:lnTo>
                 <a:lnTo>
-                  <a:pt x="0" y="771560"/>
+                  <a:pt x="0" y="1009299"/>
                 </a:lnTo>
                 <a:close/>
               </a:path>
@@ -3163,8 +3163,8 @@
         </p:nvSpPr>
         <p:spPr>
           <a:xfrm>
-            <a:off x="4254902" y="4139602"/>
-            <a:ext cx="2783189" cy="1292320"/>
+            <a:off x="3987555" y="4303755"/>
+            <a:ext cx="2455756" cy="1201753"/>
           </a:xfrm>
           <a:custGeom>
             <a:avLst/>
@@ -3173,18 +3173,18 @@
             <a:cxnLst/>
             <a:rect l="l" t="t" r="r" b="b"/>
             <a:pathLst>
-              <a:path w="2783189" h="1292320">
+              <a:path w="2455756" h="1201753">
                 <a:moveTo>
-                  <a:pt x="2783189" y="1292320"/>
+                  <a:pt x="2455756" y="1201753"/>
                 </a:moveTo>
                 <a:lnTo>
-                  <a:pt x="2783189" y="769819"/>
+                  <a:pt x="2455756" y="679251"/>
                 </a:lnTo>
                 <a:lnTo>
                   <a:pt x="0" y="0"/>
                 </a:lnTo>
                 <a:lnTo>
-                  <a:pt x="0" y="522502"/>
+                  <a:pt x="0" y="522501"/>
                 </a:lnTo>
                 <a:close/>
               </a:path>
@@ -3230,8 +3230,8 @@
         </p:nvSpPr>
         <p:spPr>
           <a:xfrm>
-            <a:off x="4166076" y="4638591"/>
-            <a:ext cx="2960840" cy="294342"/>
+            <a:off x="6504269" y="4853687"/>
+            <a:ext cx="1638041" cy="294342"/>
           </a:xfrm>
           <a:prstGeom prst="rect">
             <a:avLst/>
@@ -3265,8 +3265,8 @@
         </p:nvSpPr>
         <p:spPr>
           <a:xfrm>
-            <a:off x="7038091" y="3911443"/>
-            <a:ext cx="900444" cy="997978"/>
+            <a:off x="6443311" y="3747291"/>
+            <a:ext cx="1759958" cy="1235715"/>
           </a:xfrm>
           <a:custGeom>
             <a:avLst/>
@@ -3275,18 +3275,18 @@
             <a:cxnLst/>
             <a:rect l="l" t="t" r="r" b="b"/>
             <a:pathLst>
-              <a:path w="900444" h="997978">
+              <a:path w="1759958" h="1235715">
                 <a:moveTo>
-                  <a:pt x="900444" y="748919"/>
+                  <a:pt x="1759958" y="748918"/>
                 </a:moveTo>
                 <a:lnTo>
-                  <a:pt x="900444" y="0"/>
+                  <a:pt x="1759958" y="0"/>
                 </a:lnTo>
                 <a:lnTo>
-                  <a:pt x="0" y="249059"/>
+                  <a:pt x="0" y="486797"/>
                 </a:lnTo>
                 <a:lnTo>
-                  <a:pt x="0" y="997978"/>
+                  <a:pt x="0" y="1235715"/>
                 </a:lnTo>
                 <a:close/>
               </a:path>
@@ -3332,8 +3332,8 @@
         </p:nvSpPr>
         <p:spPr>
           <a:xfrm>
-            <a:off x="4254902" y="3390684"/>
-            <a:ext cx="2783189" cy="1518737"/>
+            <a:off x="3987555" y="3554836"/>
+            <a:ext cx="2455756" cy="1428170"/>
           </a:xfrm>
           <a:custGeom>
             <a:avLst/>
@@ -3342,18 +3342,18 @@
             <a:cxnLst/>
             <a:rect l="l" t="t" r="r" b="b"/>
             <a:pathLst>
-              <a:path w="2783189" h="1518737">
+              <a:path w="2455756" h="1428170">
                 <a:moveTo>
-                  <a:pt x="2783189" y="1518737"/>
+                  <a:pt x="2455756" y="1428170"/>
                 </a:moveTo>
                 <a:lnTo>
-                  <a:pt x="2783189" y="769818"/>
+                  <a:pt x="2455756" y="679252"/>
                 </a:lnTo>
                 <a:lnTo>
                   <a:pt x="0" y="0"/>
                 </a:lnTo>
                 <a:lnTo>
-                  <a:pt x="0" y="748918"/>
+                  <a:pt x="0" y="748919"/>
                 </a:lnTo>
                 <a:close/>
               </a:path>
@@ -3399,8 +3399,8 @@
         </p:nvSpPr>
         <p:spPr>
           <a:xfrm>
-            <a:off x="4166076" y="3880964"/>
-            <a:ext cx="2960840" cy="294342"/>
+            <a:off x="6504269" y="4096061"/>
+            <a:ext cx="1638041" cy="294342"/>
           </a:xfrm>
           <a:prstGeom prst="rect">
             <a:avLst/>
@@ -3434,8 +3434,8 @@
         </p:nvSpPr>
         <p:spPr>
           <a:xfrm>
-            <a:off x="4166076" y="4130023"/>
-            <a:ext cx="2960840" cy="249059"/>
+            <a:off x="6504269" y="4345119"/>
+            <a:ext cx="1638041" cy="249059"/>
           </a:xfrm>
           <a:prstGeom prst="rect">
             <a:avLst/>
@@ -3469,8 +3469,8 @@
         </p:nvSpPr>
         <p:spPr>
           <a:xfrm>
-            <a:off x="7038091" y="3388942"/>
-            <a:ext cx="900444" cy="771560"/>
+            <a:off x="6443311" y="3224790"/>
+            <a:ext cx="1759958" cy="1009298"/>
           </a:xfrm>
           <a:custGeom>
             <a:avLst/>
@@ -3479,18 +3479,18 @@
             <a:cxnLst/>
             <a:rect l="l" t="t" r="r" b="b"/>
             <a:pathLst>
-              <a:path w="900444" h="771560">
+              <a:path w="1759958" h="1009298">
                 <a:moveTo>
-                  <a:pt x="900444" y="522501"/>
+                  <a:pt x="1759958" y="522501"/>
                 </a:moveTo>
                 <a:lnTo>
-                  <a:pt x="900444" y="0"/>
+                  <a:pt x="1759958" y="0"/>
                 </a:lnTo>
                 <a:lnTo>
-                  <a:pt x="0" y="249059"/>
+                  <a:pt x="0" y="486797"/>
                 </a:lnTo>
                 <a:lnTo>
-                  <a:pt x="0" y="771560"/>
+                  <a:pt x="0" y="1009298"/>
                 </a:lnTo>
                 <a:close/>
               </a:path>
@@ -3536,8 +3536,8 @@
         </p:nvSpPr>
         <p:spPr>
           <a:xfrm>
-            <a:off x="4254902" y="2868183"/>
-            <a:ext cx="2783189" cy="1292319"/>
+            <a:off x="3987555" y="3032335"/>
+            <a:ext cx="2455756" cy="1201753"/>
           </a:xfrm>
           <a:custGeom>
             <a:avLst/>
@@ -3546,12 +3546,12 @@
             <a:cxnLst/>
             <a:rect l="l" t="t" r="r" b="b"/>
             <a:pathLst>
-              <a:path w="2783189" h="1292319">
+              <a:path w="2455756" h="1201753">
                 <a:moveTo>
-                  <a:pt x="2783189" y="1292319"/>
+                  <a:pt x="2455756" y="1201753"/>
                 </a:moveTo>
                 <a:lnTo>
-                  <a:pt x="2783189" y="769818"/>
+                  <a:pt x="2455756" y="679252"/>
                 </a:lnTo>
                 <a:lnTo>
                   <a:pt x="0" y="0"/>
@@ -3603,8 +3603,8 @@
         </p:nvSpPr>
         <p:spPr>
           <a:xfrm>
-            <a:off x="4166076" y="3367171"/>
-            <a:ext cx="2960840" cy="294342"/>
+            <a:off x="6504269" y="3582268"/>
+            <a:ext cx="1638041" cy="294342"/>
           </a:xfrm>
           <a:prstGeom prst="rect">
             <a:avLst/>
@@ -3638,8 +3638,8 @@
         </p:nvSpPr>
         <p:spPr>
           <a:xfrm>
-            <a:off x="7038091" y="2866441"/>
-            <a:ext cx="900444" cy="771560"/>
+            <a:off x="6443311" y="2702289"/>
+            <a:ext cx="1759958" cy="1009298"/>
           </a:xfrm>
           <a:custGeom>
             <a:avLst/>
@@ -3648,18 +3648,18 @@
             <a:cxnLst/>
             <a:rect l="l" t="t" r="r" b="b"/>
             <a:pathLst>
-              <a:path w="900444" h="771560">
+              <a:path w="1759958" h="1009298">
                 <a:moveTo>
-                  <a:pt x="900444" y="522501"/>
+                  <a:pt x="1759958" y="522501"/>
                 </a:moveTo>
                 <a:lnTo>
-                  <a:pt x="900444" y="0"/>
+                  <a:pt x="1759958" y="0"/>
                 </a:lnTo>
                 <a:lnTo>
-                  <a:pt x="0" y="249059"/>
+                  <a:pt x="0" y="486797"/>
                 </a:lnTo>
                 <a:lnTo>
-                  <a:pt x="0" y="771560"/>
+                  <a:pt x="0" y="1009298"/>
                 </a:lnTo>
                 <a:close/>
               </a:path>
@@ -3705,8 +3705,8 @@
         </p:nvSpPr>
         <p:spPr>
           <a:xfrm>
-            <a:off x="4254902" y="2345681"/>
-            <a:ext cx="2783189" cy="1292320"/>
+            <a:off x="3987555" y="2509834"/>
+            <a:ext cx="2455756" cy="1201753"/>
           </a:xfrm>
           <a:custGeom>
             <a:avLst/>
@@ -3715,18 +3715,18 @@
             <a:cxnLst/>
             <a:rect l="l" t="t" r="r" b="b"/>
             <a:pathLst>
-              <a:path w="2783189" h="1292320">
+              <a:path w="2455756" h="1201753">
                 <a:moveTo>
-                  <a:pt x="2783189" y="1292320"/>
+                  <a:pt x="2455756" y="1201753"/>
                 </a:moveTo>
                 <a:lnTo>
-                  <a:pt x="2783189" y="769819"/>
+                  <a:pt x="2455756" y="679252"/>
                 </a:lnTo>
                 <a:lnTo>
                   <a:pt x="0" y="0"/>
                 </a:lnTo>
                 <a:lnTo>
-                  <a:pt x="0" y="522502"/>
+                  <a:pt x="0" y="522501"/>
                 </a:lnTo>
                 <a:close/>
               </a:path>
@@ -3772,8 +3772,8 @@
         </p:nvSpPr>
         <p:spPr>
           <a:xfrm>
-            <a:off x="4166076" y="2844670"/>
-            <a:ext cx="2960840" cy="294342"/>
+            <a:off x="6504269" y="3059766"/>
+            <a:ext cx="1638041" cy="294342"/>
           </a:xfrm>
           <a:prstGeom prst="rect">
             <a:avLst/>
@@ -3807,8 +3807,8 @@
         </p:nvSpPr>
         <p:spPr>
           <a:xfrm>
-            <a:off x="7038091" y="2343940"/>
-            <a:ext cx="900444" cy="771560"/>
+            <a:off x="6443311" y="2179787"/>
+            <a:ext cx="1759958" cy="1009299"/>
           </a:xfrm>
           <a:custGeom>
             <a:avLst/>
@@ -3817,18 +3817,18 @@
             <a:cxnLst/>
             <a:rect l="l" t="t" r="r" b="b"/>
             <a:pathLst>
-              <a:path w="900444" h="771560">
+              <a:path w="1759958" h="1009299">
                 <a:moveTo>
-                  <a:pt x="900444" y="522501"/>
+                  <a:pt x="1759958" y="522502"/>
                 </a:moveTo>
                 <a:lnTo>
-                  <a:pt x="900444" y="0"/>
+                  <a:pt x="1759958" y="0"/>
                 </a:lnTo>
                 <a:lnTo>
-                  <a:pt x="0" y="249059"/>
+                  <a:pt x="0" y="486797"/>
                 </a:lnTo>
                 <a:lnTo>
-                  <a:pt x="0" y="771560"/>
+                  <a:pt x="0" y="1009299"/>
                 </a:lnTo>
                 <a:close/>
               </a:path>
@@ -3874,8 +3874,8 @@
         </p:nvSpPr>
         <p:spPr>
           <a:xfrm>
-            <a:off x="4254902" y="1823180"/>
-            <a:ext cx="2783189" cy="1292320"/>
+            <a:off x="3987555" y="1987333"/>
+            <a:ext cx="2455756" cy="1201753"/>
           </a:xfrm>
           <a:custGeom>
             <a:avLst/>
@@ -3884,12 +3884,12 @@
             <a:cxnLst/>
             <a:rect l="l" t="t" r="r" b="b"/>
             <a:pathLst>
-              <a:path w="2783189" h="1292320">
+              <a:path w="2455756" h="1201753">
                 <a:moveTo>
-                  <a:pt x="2783189" y="1292320"/>
+                  <a:pt x="2455756" y="1201753"/>
                 </a:moveTo>
                 <a:lnTo>
-                  <a:pt x="2783189" y="769819"/>
+                  <a:pt x="2455756" y="679251"/>
                 </a:lnTo>
                 <a:lnTo>
                   <a:pt x="0" y="0"/>
@@ -3941,8 +3941,8 @@
         </p:nvSpPr>
         <p:spPr>
           <a:xfrm>
-            <a:off x="4166076" y="2322169"/>
-            <a:ext cx="2960840" cy="294342"/>
+            <a:off x="6504269" y="2537265"/>
+            <a:ext cx="1638041" cy="294342"/>
           </a:xfrm>
           <a:prstGeom prst="rect">
             <a:avLst/>
@@ -3976,8 +3976,8 @@
         </p:nvSpPr>
         <p:spPr>
           <a:xfrm>
-            <a:off x="4254902" y="1051620"/>
-            <a:ext cx="3683633" cy="1018878"/>
+            <a:off x="3987555" y="978035"/>
+            <a:ext cx="4215714" cy="1166048"/>
           </a:xfrm>
           <a:custGeom>
             <a:avLst/>
@@ -3986,18 +3986,18 @@
             <a:cxnLst/>
             <a:rect l="l" t="t" r="r" b="b"/>
             <a:pathLst>
-              <a:path w="3683633" h="1018878">
+              <a:path w="4215714" h="1166048">
                 <a:moveTo>
-                  <a:pt x="900443" y="0"/>
+                  <a:pt x="1759958" y="0"/>
                 </a:moveTo>
                 <a:lnTo>
-                  <a:pt x="3683633" y="769819"/>
+                  <a:pt x="4215714" y="679251"/>
                 </a:lnTo>
                 <a:lnTo>
-                  <a:pt x="2783189" y="1018878"/>
+                  <a:pt x="2455756" y="1166048"/>
                 </a:lnTo>
                 <a:lnTo>
-                  <a:pt x="0" y="249059"/>
+                  <a:pt x="0" y="486797"/>
                 </a:lnTo>
                 <a:close/>
               </a:path>
@@ -4043,8 +4043,8 @@
         </p:nvSpPr>
         <p:spPr>
           <a:xfrm>
-            <a:off x="7038091" y="1821439"/>
-            <a:ext cx="900444" cy="771560"/>
+            <a:off x="6443311" y="1657286"/>
+            <a:ext cx="1759958" cy="1009298"/>
           </a:xfrm>
           <a:custGeom>
             <a:avLst/>
@@ -4053,18 +4053,18 @@
             <a:cxnLst/>
             <a:rect l="l" t="t" r="r" b="b"/>
             <a:pathLst>
-              <a:path w="900444" h="771560">
+              <a:path w="1759958" h="1009298">
                 <a:moveTo>
-                  <a:pt x="900444" y="522501"/>
+                  <a:pt x="1759958" y="522501"/>
                 </a:moveTo>
                 <a:lnTo>
-                  <a:pt x="900444" y="0"/>
+                  <a:pt x="1759958" y="0"/>
                 </a:lnTo>
                 <a:lnTo>
-                  <a:pt x="0" y="249059"/>
+                  <a:pt x="0" y="486797"/>
                 </a:lnTo>
                 <a:lnTo>
-                  <a:pt x="0" y="771560"/>
+                  <a:pt x="0" y="1009298"/>
                 </a:lnTo>
                 <a:close/>
               </a:path>
@@ -4110,8 +4110,8 @@
         </p:nvSpPr>
         <p:spPr>
           <a:xfrm>
-            <a:off x="4254902" y="1300679"/>
-            <a:ext cx="2783189" cy="1292320"/>
+            <a:off x="3987555" y="1464832"/>
+            <a:ext cx="2455756" cy="1201752"/>
           </a:xfrm>
           <a:custGeom>
             <a:avLst/>
@@ -4120,12 +4120,12 @@
             <a:cxnLst/>
             <a:rect l="l" t="t" r="r" b="b"/>
             <a:pathLst>
-              <a:path w="2783189" h="1292320">
+              <a:path w="2455756" h="1201752">
                 <a:moveTo>
-                  <a:pt x="2783189" y="1292320"/>
+                  <a:pt x="2455756" y="1201752"/>
                 </a:moveTo>
                 <a:lnTo>
-                  <a:pt x="2783189" y="769819"/>
+                  <a:pt x="2455756" y="679251"/>
                 </a:lnTo>
                 <a:lnTo>
                   <a:pt x="0" y="0"/>
@@ -4177,8 +4177,8 @@
         </p:nvSpPr>
         <p:spPr>
           <a:xfrm>
-            <a:off x="4166076" y="1799668"/>
-            <a:ext cx="2960840" cy="294342"/>
+            <a:off x="6504269" y="2014764"/>
+            <a:ext cx="1638041" cy="294342"/>
           </a:xfrm>
           <a:prstGeom prst="rect">
             <a:avLst/>
@@ -4212,7 +4212,7 @@
         </p:nvSpPr>
         <p:spPr>
           <a:xfrm>
-            <a:off x="3832546" y="296606"/>
+            <a:off x="3831240" y="223020"/>
             <a:ext cx="4528344" cy="430193"/>
           </a:xfrm>
           <a:prstGeom prst="rect">
@@ -4247,7 +4247,7 @@
         </p:nvCxnSpPr>
         <p:spPr>
           <a:xfrm flipH="1">
-            <a:off x="5417467" y="5466755"/>
+            <a:off x="5416161" y="5540341"/>
             <a:ext cx="461891" cy="487668"/>
           </a:xfrm>
           <a:prstGeom prst="line">
@@ -4284,8 +4284,8 @@
         </p:nvCxnSpPr>
         <p:spPr>
           <a:xfrm>
-            <a:off x="6096718" y="5466755"/>
-            <a:ext cx="0" cy="627002"/>
+            <a:off x="6095412" y="5540341"/>
+            <a:ext cx="0" cy="627001"/>
           </a:xfrm>
           <a:prstGeom prst="line">
             <a:avLst/>
@@ -4321,7 +4321,7 @@
         </p:nvCxnSpPr>
         <p:spPr>
           <a:xfrm>
-            <a:off x="6314079" y="5466755"/>
+            <a:off x="6312773" y="5540341"/>
             <a:ext cx="461891" cy="487668"/>
           </a:xfrm>
           <a:prstGeom prst="line">
@@ -4358,7 +4358,7 @@
         </p:nvSpPr>
         <p:spPr>
           <a:xfrm>
-            <a:off x="4790465" y="6196951"/>
+            <a:off x="4789159" y="6270536"/>
             <a:ext cx="2612506" cy="350947"/>
           </a:xfrm>
           <a:prstGeom prst="rect">

</xml_diff>